<commit_message>
Compare LangCache distance thresholds in Lab 3
</commit_message>
<xml_diff>
--- a/slides/cvs-redis-iris-workshop.pptx
+++ b/slides/cvs-redis-iris-workshop.pptx
@@ -4970,7 +4970,7 @@
                 </a:solidFill>
                 <a:latin typeface="Arial"/>
               </a:rPr>
-              <a:t>Use RedisVL's adapter to check, store on a miss, then check a rephrasing.</a:t>
+              <a:t>Store one answer, then check the same rephrasing at three distance thresholds.</a:t>
             </a:r>
           </a:p>
         </p:txBody>
@@ -4983,8 +4983,8 @@
         </p:nvSpPr>
         <p:spPr>
           <a:xfrm>
-            <a:off x="7909560" y="1975104"/>
-            <a:ext cx="3703320" cy="2743200"/>
+            <a:off x="7589520" y="1975104"/>
+            <a:ext cx="4023360" cy="2743200"/>
           </a:xfrm>
           <a:prstGeom prst="rect">
             <a:avLst/>
@@ -5003,77 +5003,77 @@
               </a:spcAft>
             </a:pPr>
             <a:r>
-              <a:rPr sz="1600" b="0">
+              <a:rPr sz="1500" b="0">
                 <a:solidFill>
                   <a:srgbClr val="131E26"/>
                 </a:solidFill>
                 <a:latin typeface="Menlo"/>
               </a:rPr>
-              <a:t>hits = cache.check(prompt=first,</a:t>
-            </a:r>
-          </a:p>
-          <a:p>
-            <a:pPr>
-              <a:spcAft>
-                <a:spcPts val="900"/>
-              </a:spcAft>
-            </a:pPr>
-            <a:r>
-              <a:rPr sz="1600" b="0">
+              <a:t>for limit in (0.02, 0.10, 0.40):</a:t>
+            </a:r>
+          </a:p>
+          <a:p>
+            <a:pPr>
+              <a:spcAft>
+                <a:spcPts val="900"/>
+              </a:spcAft>
+            </a:pPr>
+            <a:r>
+              <a:rPr sz="1500" b="0">
                 <a:solidFill>
                   <a:srgbClr val="131E26"/>
                 </a:solidFill>
                 <a:latin typeface="Menlo"/>
               </a:rPr>
-              <a:t>  distance_threshold=0.1)</a:t>
-            </a:r>
-          </a:p>
-          <a:p>
-            <a:pPr>
-              <a:spcAft>
-                <a:spcPts val="900"/>
-              </a:spcAft>
-            </a:pPr>
-            <a:r>
-              <a:rPr sz="1600" b="0">
+              <a:t>  hits = cache.check(</a:t>
+            </a:r>
+          </a:p>
+          <a:p>
+            <a:pPr>
+              <a:spcAft>
+                <a:spcPts val="900"/>
+              </a:spcAft>
+            </a:pPr>
+            <a:r>
+              <a:rPr sz="1500" b="0">
                 <a:solidFill>
                   <a:srgbClr val="131E26"/>
                 </a:solidFill>
                 <a:latin typeface="Menlo"/>
               </a:rPr>
-              <a:t>if not hits:</a:t>
-            </a:r>
-          </a:p>
-          <a:p>
-            <a:pPr>
-              <a:spcAft>
-                <a:spcPts val="900"/>
-              </a:spcAft>
-            </a:pPr>
-            <a:r>
-              <a:rPr sz="1600" b="0">
+              <a:t>    prompt=similar,</a:t>
+            </a:r>
+          </a:p>
+          <a:p>
+            <a:pPr>
+              <a:spcAft>
+                <a:spcPts val="900"/>
+              </a:spcAft>
+            </a:pPr>
+            <a:r>
+              <a:rPr sz="1500" b="0">
                 <a:solidFill>
                   <a:srgbClr val="131E26"/>
                 </a:solidFill>
                 <a:latin typeface="Menlo"/>
               </a:rPr>
-              <a:t>  cache.store(prompt=first,</a:t>
-            </a:r>
-          </a:p>
-          <a:p>
-            <a:pPr>
-              <a:spcAft>
-                <a:spcPts val="900"/>
-              </a:spcAft>
-            </a:pPr>
-            <a:r>
-              <a:rPr sz="1600" b="0">
+              <a:t>    distance_threshold=limit)</a:t>
+            </a:r>
+          </a:p>
+          <a:p>
+            <a:pPr>
+              <a:spcAft>
+                <a:spcPts val="900"/>
+              </a:spcAft>
+            </a:pPr>
+            <a:r>
+              <a:rPr sz="1500" b="0">
                 <a:solidFill>
                   <a:srgbClr val="131E26"/>
                 </a:solidFill>
                 <a:latin typeface="Menlo"/>
               </a:rPr>
-              <a:t>    response=answer)</a:t>
+              <a:t>  print(limit, bool(hits))</a:t>
             </a:r>
           </a:p>
         </p:txBody>

</xml_diff>

<commit_message>
updates exercise path names
</commit_message>
<xml_diff>
--- a/slides/cvs-redis-iris-workshop.pptx
+++ b/slides/cvs-redis-iris-workshop.pptx
@@ -584,7 +584,7 @@
           <a:lstStyle/>
           <a:p>
             <a:r>
-              <a:t>Source: https://redis.io/docs/latest/develop/ai/context-engine/agent-memory/python-sdk-quickstart/ . Workshop guide: exercises/lab_4/README.md</a:t>
+              <a:t>Source: https://redis.io/docs/latest/develop/ai/context-engine/agent-memory/python-sdk-quickstart/ . Workshop guide: exercises/lab_4_agent_memory/README.md</a:t>
             </a:r>
           </a:p>
         </p:txBody>
@@ -864,7 +864,7 @@
           <a:lstStyle/>
           <a:p>
             <a:r>
-              <a:t>Sources: https://docs.redisvl.com/en/latest/user_guide/04_vectorizers.html ; https://docs.redisvl.com/en/latest/api/searchindex.html . Workshop guide: exercises/lab_1/README.md</a:t>
+              <a:t>Sources: https://docs.redisvl.com/en/latest/user_guide/04_vectorizers.html ; https://docs.redisvl.com/en/latest/api/searchindex.html . Workshop guide: exercises/lab_1_vector_search/README.md</a:t>
             </a:r>
           </a:p>
         </p:txBody>
@@ -934,7 +934,7 @@
           <a:lstStyle/>
           <a:p>
             <a:r>
-              <a:t>Source: https://redis.io/docs/latest/develop/ai/context-engine/context-retriever/quickstart/ . Workshop guide: exercises/lab_2/README.md</a:t>
+              <a:t>Source: https://redis.io/docs/latest/develop/ai/context-engine/context-retriever/quickstart/ . Workshop guide: exercises/lab_2_context_retriever/README.md</a:t>
             </a:r>
           </a:p>
         </p:txBody>
@@ -1074,7 +1074,7 @@
           <a:lstStyle/>
           <a:p>
             <a:r>
-              <a:t>Source: https://redis.io/tutorials/getting-started-with-redis-iris/ . Workshop guide: exercises/lab_2/README.md</a:t>
+              <a:t>Source: https://redis.io/tutorials/getting-started-with-redis-iris/ . Workshop guide: exercises/lab_2_context_retriever/README.md</a:t>
             </a:r>
           </a:p>
         </p:txBody>
@@ -1144,7 +1144,7 @@
           <a:lstStyle/>
           <a:p>
             <a:r>
-              <a:t>Sources: https://redis.io/docs/latest/operate/rc/langcache/create-service/ ; https://redis.io/docs/latest/operate/rc/langcache/use-langcache/ ; https://docs.redisvl.com/en/latest/user_guide/13_langcache_semantic_cache.html . Workshop guide: exercises/lab_3/README.md</a:t>
+              <a:t>Sources: https://redis.io/docs/latest/operate/rc/langcache/create-service/ ; https://redis.io/docs/latest/operate/rc/langcache/use-langcache/ ; https://docs.redisvl.com/en/latest/user_guide/13_langcache_semantic_cache.html . Workshop guide: exercises/lab_3_langcache/README.md</a:t>
             </a:r>
           </a:p>
         </p:txBody>
@@ -5340,7 +5340,7 @@
                 </a:solidFill>
                 <a:latin typeface="Menlo"/>
               </a:rPr>
-              <a:t>python exercises/lab_4/04_memory.py write</a:t>
+              <a:t>python exercises/lab_4_agent_memory/04_memory.py write</a:t>
             </a:r>
           </a:p>
           <a:p>
@@ -5363,7 +5363,7 @@
                 </a:solidFill>
                 <a:latin typeface="Menlo"/>
               </a:rPr>
-              <a:t>python exercises/lab_4/04_memory.py read</a:t>
+              <a:t>python exercises/lab_4_agent_memory/04_memory.py read</a:t>
             </a:r>
           </a:p>
         </p:txBody>
@@ -7393,7 +7393,7 @@
                 </a:solidFill>
                 <a:latin typeface="Menlo"/>
               </a:rPr>
-              <a:t>python exercises/lab_1/01_vector.py</a:t>
+              <a:t>python exercises/lab_1_vector_search/01_vector.py</a:t>
             </a:r>
           </a:p>
           <a:p>
@@ -7973,7 +7973,7 @@
                 </a:solidFill>
                 <a:latin typeface="Arial"/>
               </a:rPr>
-              <a:t>Create a surface from exercises/lab_2/models.py and your Redis endpoint.</a:t>
+              <a:t>Create a surface from exercises/lab_2_context_retriever/models.py and your Redis endpoint.</a:t>
             </a:r>
           </a:p>
           <a:p>
@@ -8067,7 +8067,7 @@
                 </a:solidFill>
                 <a:latin typeface="Menlo"/>
               </a:rPr>
-              <a:t>ctxctl surface create --models exercises/lab_2/models.py ...</a:t>
+              <a:t>ctxctl surface create --models exercises/lab_2_context_retriever/models.py ...</a:t>
             </a:r>
           </a:p>
           <a:p>

</xml_diff>